<commit_message>
Update sample project code
</commit_message>
<xml_diff>
--- a/заняття_9_django_forms_cbv/презентація/django_forms_lesson.pptx
+++ b/заняття_9_django_forms_cbv/презентація/django_forms_lesson.pptx
@@ -2527,7 +2527,7 @@
         </p:nvSpPr>
         <p:spPr>
           <a:xfrm>
-            <a:off x="502920" y="960120"/>
+            <a:off x="420370" y="795020"/>
             <a:ext cx="5029200" cy="4114800"/>
           </a:xfrm>
           <a:prstGeom prst="rect">
@@ -2559,7 +2559,7 @@
         </p:nvSpPr>
         <p:spPr>
           <a:xfrm>
-            <a:off x="612648" y="1005840"/>
+            <a:off x="530098" y="840740"/>
             <a:ext cx="4846320" cy="201168"/>
           </a:xfrm>
           <a:prstGeom prst="rect">
@@ -2598,7 +2598,7 @@
         </p:nvSpPr>
         <p:spPr>
           <a:xfrm>
-            <a:off x="630936" y="1197864"/>
+            <a:off x="548386" y="1032764"/>
             <a:ext cx="4773168" cy="3785616"/>
           </a:xfrm>
           <a:prstGeom prst="rect">
@@ -2617,9 +2617,8 @@
             <a:r>
               <a:rPr lang="en-US" sz="900" dirty="0">
                 <a:solidFill>
-                  <a:schemeClr val="tx1">
-                    <a:lumMod val="50000"/>
-                    <a:lumOff val="50000"/>
+                  <a:schemeClr val="accent3">
+                    <a:lumMod val="75000"/>
                   </a:schemeClr>
                 </a:solidFill>
                 <a:latin typeface="Consolas" pitchFamily="34" charset="0"/>
@@ -2630,9 +2629,8 @@
             </a:r>
             <a:endParaRPr lang="en-US" sz="900" dirty="0">
               <a:solidFill>
-                <a:schemeClr val="tx1">
-                  <a:lumMod val="50000"/>
-                  <a:lumOff val="50000"/>
+                <a:schemeClr val="accent3">
+                  <a:lumMod val="75000"/>
                 </a:schemeClr>
               </a:solidFill>
             </a:endParaRPr>
@@ -2696,7 +2694,80 @@
                 <a:ea typeface="Consolas" pitchFamily="34" charset="-122"/>
                 <a:cs typeface="Consolas" pitchFamily="34" charset="-120"/>
               </a:rPr>
-              <a:t>    {{ form.as_p }}        {# або вручну: #}</a:t>
+              <a:t>    {{ form.as_p }}        </a:t>
+            </a:r>
+            <a:r>
+              <a:rPr lang="en-US" sz="900" dirty="0">
+                <a:solidFill>
+                  <a:schemeClr val="accent3">
+                    <a:lumMod val="75000"/>
+                  </a:schemeClr>
+                </a:solidFill>
+                <a:latin typeface="Consolas" pitchFamily="34" charset="0"/>
+                <a:ea typeface="Consolas" pitchFamily="34" charset="-122"/>
+                <a:cs typeface="Consolas" pitchFamily="34" charset="-120"/>
+              </a:rPr>
+              <a:t>{# або вручну: #}</a:t>
+            </a:r>
+            <a:endParaRPr lang="en-US" sz="900" dirty="0">
+              <a:solidFill>
+                <a:schemeClr val="accent3">
+                  <a:lumMod val="75000"/>
+                </a:schemeClr>
+              </a:solidFill>
+            </a:endParaRPr>
+          </a:p>
+          <a:p>
+            <a:pPr marL="0" indent="0">
+              <a:buNone/>
+            </a:pPr>
+            <a:endParaRPr lang="en-US" sz="900" dirty="0">
+              <a:solidFill>
+                <a:schemeClr val="accent3">
+                  <a:lumMod val="75000"/>
+                </a:schemeClr>
+              </a:solidFill>
+            </a:endParaRPr>
+          </a:p>
+          <a:p>
+            <a:pPr marL="0" indent="0">
+              <a:buNone/>
+            </a:pPr>
+            <a:r>
+              <a:rPr lang="en-US" sz="900" dirty="0">
+                <a:solidFill>
+                  <a:schemeClr val="accent3">
+                    <a:lumMod val="75000"/>
+                  </a:schemeClr>
+                </a:solidFill>
+                <a:latin typeface="Consolas" pitchFamily="34" charset="0"/>
+                <a:ea typeface="Consolas" pitchFamily="34" charset="-122"/>
+                <a:cs typeface="Consolas" pitchFamily="34" charset="-120"/>
+              </a:rPr>
+              <a:t>    {# РУЧНЕ відображення #}</a:t>
+            </a:r>
+            <a:endParaRPr lang="en-US" sz="900" dirty="0">
+              <a:solidFill>
+                <a:schemeClr val="accent3">
+                  <a:lumMod val="75000"/>
+                </a:schemeClr>
+              </a:solidFill>
+            </a:endParaRPr>
+          </a:p>
+          <a:p>
+            <a:pPr marL="0" indent="0">
+              <a:buNone/>
+            </a:pPr>
+            <a:r>
+              <a:rPr lang="en-US" sz="900" dirty="0">
+                <a:solidFill>
+                  <a:srgbClr val="E2E8F0"/>
+                </a:solidFill>
+                <a:latin typeface="Consolas" pitchFamily="34" charset="0"/>
+                <a:ea typeface="Consolas" pitchFamily="34" charset="-122"/>
+                <a:cs typeface="Consolas" pitchFamily="34" charset="-120"/>
+              </a:rPr>
+              <a:t>    &lt;div&gt;</a:t>
             </a:r>
             <a:endParaRPr lang="en-US" sz="900" dirty="0"/>
           </a:p>
@@ -2704,6 +2775,17 @@
             <a:pPr marL="0" indent="0">
               <a:buNone/>
             </a:pPr>
+            <a:r>
+              <a:rPr lang="en-US" sz="900" dirty="0">
+                <a:solidFill>
+                  <a:srgbClr val="E2E8F0"/>
+                </a:solidFill>
+                <a:latin typeface="Consolas" pitchFamily="34" charset="0"/>
+                <a:ea typeface="Consolas" pitchFamily="34" charset="-122"/>
+                <a:cs typeface="Consolas" pitchFamily="34" charset="-120"/>
+              </a:rPr>
+              <a:t>        &lt;label for="{{ form.name.id_for_label }}"&gt;</a:t>
+            </a:r>
             <a:endParaRPr lang="en-US" sz="900" dirty="0"/>
           </a:p>
           <a:p>
@@ -2719,7 +2801,7 @@
                 <a:ea typeface="Consolas" pitchFamily="34" charset="-122"/>
                 <a:cs typeface="Consolas" pitchFamily="34" charset="-120"/>
               </a:rPr>
-              <a:t>    {# РУЧНЕ відображення #}</a:t>
+              <a:t>            {{ form.name.label }}</a:t>
             </a:r>
             <a:endParaRPr lang="en-US" sz="900" dirty="0"/>
           </a:p>
@@ -2736,7 +2818,7 @@
                 <a:ea typeface="Consolas" pitchFamily="34" charset="-122"/>
                 <a:cs typeface="Consolas" pitchFamily="34" charset="-120"/>
               </a:rPr>
-              <a:t>    &lt;div&gt;</a:t>
+              <a:t>        &lt;/label&gt;</a:t>
             </a:r>
             <a:endParaRPr lang="en-US" sz="900" dirty="0"/>
           </a:p>
@@ -2753,7 +2835,7 @@
                 <a:ea typeface="Consolas" pitchFamily="34" charset="-122"/>
                 <a:cs typeface="Consolas" pitchFamily="34" charset="-120"/>
               </a:rPr>
-              <a:t>        &lt;label for="{{ form.name.id_for_label }}"&gt;</a:t>
+              <a:t>        {{ form.name }}</a:t>
             </a:r>
             <a:endParaRPr lang="en-US" sz="900" dirty="0"/>
           </a:p>
@@ -2770,7 +2852,7 @@
                 <a:ea typeface="Consolas" pitchFamily="34" charset="-122"/>
                 <a:cs typeface="Consolas" pitchFamily="34" charset="-120"/>
               </a:rPr>
-              <a:t>            {{ form.name.label }}</a:t>
+              <a:t>        {% if form.name.errors %}</a:t>
             </a:r>
             <a:endParaRPr lang="en-US" sz="900" dirty="0"/>
           </a:p>
@@ -2787,7 +2869,7 @@
                 <a:ea typeface="Consolas" pitchFamily="34" charset="-122"/>
                 <a:cs typeface="Consolas" pitchFamily="34" charset="-120"/>
               </a:rPr>
-              <a:t>        &lt;/label&gt;</a:t>
+              <a:t>            &lt;ul class="errors"&gt;</a:t>
             </a:r>
             <a:endParaRPr lang="en-US" sz="900" dirty="0"/>
           </a:p>
@@ -2804,7 +2886,7 @@
                 <a:ea typeface="Consolas" pitchFamily="34" charset="-122"/>
                 <a:cs typeface="Consolas" pitchFamily="34" charset="-120"/>
               </a:rPr>
-              <a:t>        {{ form.name }}</a:t>
+              <a:t>                {% for error in form.name.errors %}</a:t>
             </a:r>
             <a:endParaRPr lang="en-US" sz="900" dirty="0"/>
           </a:p>
@@ -2821,7 +2903,7 @@
                 <a:ea typeface="Consolas" pitchFamily="34" charset="-122"/>
                 <a:cs typeface="Consolas" pitchFamily="34" charset="-120"/>
               </a:rPr>
-              <a:t>        {% if form.name.errors %}</a:t>
+              <a:t>                    &lt;li&gt;{{ error }}&lt;/li&gt;</a:t>
             </a:r>
             <a:endParaRPr lang="en-US" sz="900" dirty="0"/>
           </a:p>
@@ -2838,7 +2920,7 @@
                 <a:ea typeface="Consolas" pitchFamily="34" charset="-122"/>
                 <a:cs typeface="Consolas" pitchFamily="34" charset="-120"/>
               </a:rPr>
-              <a:t>            &lt;ul class="errors"&gt;</a:t>
+              <a:t>                {% endfor %}</a:t>
             </a:r>
             <a:endParaRPr lang="en-US" sz="900" dirty="0"/>
           </a:p>
@@ -2855,7 +2937,7 @@
                 <a:ea typeface="Consolas" pitchFamily="34" charset="-122"/>
                 <a:cs typeface="Consolas" pitchFamily="34" charset="-120"/>
               </a:rPr>
-              <a:t>                {% for error in form.name.errors %}</a:t>
+              <a:t>            &lt;/ul&gt;</a:t>
             </a:r>
             <a:endParaRPr lang="en-US" sz="900" dirty="0"/>
           </a:p>
@@ -2872,7 +2954,7 @@
                 <a:ea typeface="Consolas" pitchFamily="34" charset="-122"/>
                 <a:cs typeface="Consolas" pitchFamily="34" charset="-120"/>
               </a:rPr>
-              <a:t>                    &lt;li&gt;{{ error }}&lt;/li&gt;</a:t>
+              <a:t>        {% endif %}</a:t>
             </a:r>
             <a:endParaRPr lang="en-US" sz="900" dirty="0"/>
           </a:p>
@@ -2889,7 +2971,7 @@
                 <a:ea typeface="Consolas" pitchFamily="34" charset="-122"/>
                 <a:cs typeface="Consolas" pitchFamily="34" charset="-120"/>
               </a:rPr>
-              <a:t>                {% endfor %}</a:t>
+              <a:t>        &lt;small&gt;{{ form.name.help_text }}&lt;/small&gt;</a:t>
             </a:r>
             <a:endParaRPr lang="en-US" sz="900" dirty="0"/>
           </a:p>
@@ -2906,7 +2988,7 @@
                 <a:ea typeface="Consolas" pitchFamily="34" charset="-122"/>
                 <a:cs typeface="Consolas" pitchFamily="34" charset="-120"/>
               </a:rPr>
-              <a:t>            &lt;/ul&gt;</a:t>
+              <a:t>    &lt;/div&gt;</a:t>
             </a:r>
             <a:endParaRPr lang="en-US" sz="900" dirty="0"/>
           </a:p>
@@ -2914,6 +2996,12 @@
             <a:pPr marL="0" indent="0">
               <a:buNone/>
             </a:pPr>
+            <a:endParaRPr lang="en-US" sz="900" dirty="0"/>
+          </a:p>
+          <a:p>
+            <a:pPr marL="0" indent="0">
+              <a:buNone/>
+            </a:pPr>
             <a:r>
               <a:rPr lang="en-US" sz="900" dirty="0">
                 <a:solidFill>
@@ -2923,7 +3011,7 @@
                 <a:ea typeface="Consolas" pitchFamily="34" charset="-122"/>
                 <a:cs typeface="Consolas" pitchFamily="34" charset="-120"/>
               </a:rPr>
-              <a:t>        {% endif %}</a:t>
+              <a:t>    &lt;button type="submit"&gt;Зберегти&lt;/button&gt;</a:t>
             </a:r>
             <a:endParaRPr lang="en-US" sz="900" dirty="0"/>
           </a:p>
@@ -2940,67 +3028,10 @@
                 <a:ea typeface="Consolas" pitchFamily="34" charset="-122"/>
                 <a:cs typeface="Consolas" pitchFamily="34" charset="-120"/>
               </a:rPr>
-              <a:t>        &lt;small&gt;{{ form.name.help_text }}&lt;/small&gt;</a:t>
+              <a:t>&lt;/form&gt;</a:t>
             </a:r>
             <a:endParaRPr lang="en-US" sz="900" dirty="0"/>
           </a:p>
-          <a:p>
-            <a:pPr marL="0" indent="0">
-              <a:buNone/>
-            </a:pPr>
-            <a:r>
-              <a:rPr lang="en-US" sz="900" dirty="0">
-                <a:solidFill>
-                  <a:srgbClr val="E2E8F0"/>
-                </a:solidFill>
-                <a:latin typeface="Consolas" pitchFamily="34" charset="0"/>
-                <a:ea typeface="Consolas" pitchFamily="34" charset="-122"/>
-                <a:cs typeface="Consolas" pitchFamily="34" charset="-120"/>
-              </a:rPr>
-              <a:t>    &lt;/div&gt;</a:t>
-            </a:r>
-            <a:endParaRPr lang="en-US" sz="900" dirty="0"/>
-          </a:p>
-          <a:p>
-            <a:pPr marL="0" indent="0">
-              <a:buNone/>
-            </a:pPr>
-            <a:endParaRPr lang="en-US" sz="900" dirty="0"/>
-          </a:p>
-          <a:p>
-            <a:pPr marL="0" indent="0">
-              <a:buNone/>
-            </a:pPr>
-            <a:r>
-              <a:rPr lang="en-US" sz="900" dirty="0">
-                <a:solidFill>
-                  <a:srgbClr val="E2E8F0"/>
-                </a:solidFill>
-                <a:latin typeface="Consolas" pitchFamily="34" charset="0"/>
-                <a:ea typeface="Consolas" pitchFamily="34" charset="-122"/>
-                <a:cs typeface="Consolas" pitchFamily="34" charset="-120"/>
-              </a:rPr>
-              <a:t>    &lt;button type="submit"&gt;Зберегти&lt;/button&gt;</a:t>
-            </a:r>
-            <a:endParaRPr lang="en-US" sz="900" dirty="0"/>
-          </a:p>
-          <a:p>
-            <a:pPr marL="0" indent="0">
-              <a:buNone/>
-            </a:pPr>
-            <a:r>
-              <a:rPr lang="en-US" sz="900" dirty="0">
-                <a:solidFill>
-                  <a:srgbClr val="E2E8F0"/>
-                </a:solidFill>
-                <a:latin typeface="Consolas" pitchFamily="34" charset="0"/>
-                <a:ea typeface="Consolas" pitchFamily="34" charset="-122"/>
-                <a:cs typeface="Consolas" pitchFamily="34" charset="-120"/>
-              </a:rPr>
-              <a:t>&lt;/form&gt;</a:t>
-            </a:r>
-            <a:endParaRPr lang="en-US" sz="900" dirty="0"/>
-          </a:p>
         </p:txBody>
       </p:sp>
       <p:sp>
@@ -3011,7 +3042,7 @@
         </p:nvSpPr>
         <p:spPr>
           <a:xfrm>
-            <a:off x="5623560" y="960120"/>
+            <a:off x="5541010" y="795020"/>
             <a:ext cx="3108960" cy="1645920"/>
           </a:xfrm>
           <a:prstGeom prst="rect">
@@ -3050,7 +3081,7 @@
         </p:nvSpPr>
         <p:spPr>
           <a:xfrm>
-            <a:off x="5623560" y="960120"/>
+            <a:off x="5541010" y="795020"/>
             <a:ext cx="3108960" cy="365760"/>
           </a:xfrm>
           <a:prstGeom prst="rect">
@@ -3082,7 +3113,7 @@
         </p:nvSpPr>
         <p:spPr>
           <a:xfrm>
-            <a:off x="5715000" y="960120"/>
+            <a:off x="5632450" y="795020"/>
             <a:ext cx="2926080" cy="365760"/>
           </a:xfrm>
           <a:prstGeom prst="rect">
@@ -3118,7 +3149,7 @@
         </p:nvSpPr>
         <p:spPr>
           <a:xfrm>
-            <a:off x="5687568" y="1417320"/>
+            <a:off x="5605018" y="1252220"/>
             <a:ext cx="2999232" cy="1097280"/>
           </a:xfrm>
           <a:prstGeom prst="rect">
@@ -3188,7 +3219,7 @@
         </p:nvSpPr>
         <p:spPr>
           <a:xfrm>
-            <a:off x="5623560" y="2697480"/>
+            <a:off x="5541010" y="2532380"/>
             <a:ext cx="3108960" cy="2377440"/>
           </a:xfrm>
           <a:prstGeom prst="rect">
@@ -3227,7 +3258,7 @@
         </p:nvSpPr>
         <p:spPr>
           <a:xfrm>
-            <a:off x="5687568" y="2761488"/>
+            <a:off x="5605018" y="2596388"/>
             <a:ext cx="2926080" cy="320040"/>
           </a:xfrm>
           <a:prstGeom prst="rect">
@@ -3263,7 +3294,7 @@
         </p:nvSpPr>
         <p:spPr>
           <a:xfrm>
-            <a:off x="5687568" y="3136392"/>
+            <a:off x="5605018" y="2971292"/>
             <a:ext cx="1874520" cy="292608"/>
           </a:xfrm>
           <a:prstGeom prst="rect">
@@ -3302,7 +3333,7 @@
         </p:nvSpPr>
         <p:spPr>
           <a:xfrm>
-            <a:off x="7571232" y="3136392"/>
+            <a:off x="7488682" y="2971292"/>
             <a:ext cx="1078992" cy="292608"/>
           </a:xfrm>
           <a:prstGeom prst="rect">
@@ -3338,7 +3369,7 @@
         </p:nvSpPr>
         <p:spPr>
           <a:xfrm>
-            <a:off x="5687568" y="3456432"/>
+            <a:off x="5605018" y="3291332"/>
             <a:ext cx="1874520" cy="292608"/>
           </a:xfrm>
           <a:prstGeom prst="rect">
@@ -3377,7 +3408,7 @@
         </p:nvSpPr>
         <p:spPr>
           <a:xfrm>
-            <a:off x="7571232" y="3456432"/>
+            <a:off x="7488682" y="3291332"/>
             <a:ext cx="1078992" cy="292608"/>
           </a:xfrm>
           <a:prstGeom prst="rect">
@@ -3413,7 +3444,7 @@
         </p:nvSpPr>
         <p:spPr>
           <a:xfrm>
-            <a:off x="5687568" y="3776472"/>
+            <a:off x="5605018" y="3611372"/>
             <a:ext cx="1874520" cy="292608"/>
           </a:xfrm>
           <a:prstGeom prst="rect">
@@ -3452,7 +3483,7 @@
         </p:nvSpPr>
         <p:spPr>
           <a:xfrm>
-            <a:off x="7571232" y="3776472"/>
+            <a:off x="7488682" y="3611372"/>
             <a:ext cx="1078992" cy="292608"/>
           </a:xfrm>
           <a:prstGeom prst="rect">
@@ -3488,7 +3519,7 @@
         </p:nvSpPr>
         <p:spPr>
           <a:xfrm>
-            <a:off x="5687568" y="4096512"/>
+            <a:off x="5605018" y="3931412"/>
             <a:ext cx="1874520" cy="292608"/>
           </a:xfrm>
           <a:prstGeom prst="rect">
@@ -3527,7 +3558,7 @@
         </p:nvSpPr>
         <p:spPr>
           <a:xfrm>
-            <a:off x="7571232" y="4096512"/>
+            <a:off x="7488682" y="3931412"/>
             <a:ext cx="1078992" cy="292608"/>
           </a:xfrm>
           <a:prstGeom prst="rect">
@@ -3563,7 +3594,7 @@
         </p:nvSpPr>
         <p:spPr>
           <a:xfrm>
-            <a:off x="5687568" y="4416552"/>
+            <a:off x="5605018" y="4251452"/>
             <a:ext cx="1874520" cy="292608"/>
           </a:xfrm>
           <a:prstGeom prst="rect">
@@ -3602,7 +3633,7 @@
         </p:nvSpPr>
         <p:spPr>
           <a:xfrm>
-            <a:off x="7571232" y="4416552"/>
+            <a:off x="7488682" y="4251452"/>
             <a:ext cx="1078992" cy="292608"/>
           </a:xfrm>
           <a:prstGeom prst="rect">
@@ -3638,7 +3669,7 @@
         </p:nvSpPr>
         <p:spPr>
           <a:xfrm>
-            <a:off x="5687568" y="4736592"/>
+            <a:off x="5605018" y="4571492"/>
             <a:ext cx="1874520" cy="292608"/>
           </a:xfrm>
           <a:prstGeom prst="rect">
@@ -3677,7 +3708,7 @@
         </p:nvSpPr>
         <p:spPr>
           <a:xfrm>
-            <a:off x="7571232" y="4736592"/>
+            <a:off x="7488682" y="4571492"/>
             <a:ext cx="1078992" cy="292608"/>
           </a:xfrm>
           <a:prstGeom prst="rect">
@@ -6148,7 +6179,7 @@
         <p:spPr>
           <a:xfrm>
             <a:off x="502920" y="932688"/>
-            <a:ext cx="5303520" cy="4160520"/>
+            <a:ext cx="5303520" cy="4046220"/>
           </a:xfrm>
           <a:prstGeom prst="rect">
             <a:avLst/>
@@ -21105,7 +21136,29 @@
                 <a:ea typeface="Consolas" pitchFamily="34" charset="-122"/>
                 <a:cs typeface="Consolas" pitchFamily="34" charset="-120"/>
               </a:rPr>
-              <a:t>            return redirect("courses:list")         </a:t>
+              <a:t>            return redirect("</a:t>
+            </a:r>
+            <a:r>
+              <a:rPr lang="en-US" sz="950" dirty="0" err="1">
+                <a:solidFill>
+                  <a:srgbClr val="E2E8F0"/>
+                </a:solidFill>
+                <a:latin typeface="Consolas" pitchFamily="34" charset="0"/>
+                <a:ea typeface="Consolas" pitchFamily="34" charset="-122"/>
+                <a:cs typeface="Consolas" pitchFamily="34" charset="-120"/>
+              </a:rPr>
+              <a:t>courses_list</a:t>
+            </a:r>
+            <a:r>
+              <a:rPr lang="en-US" sz="950" dirty="0">
+                <a:solidFill>
+                  <a:srgbClr val="E2E8F0"/>
+                </a:solidFill>
+                <a:latin typeface="Consolas" pitchFamily="34" charset="0"/>
+                <a:ea typeface="Consolas" pitchFamily="34" charset="-122"/>
+                <a:cs typeface="Consolas" pitchFamily="34" charset="-120"/>
+              </a:rPr>
+              <a:t>")         </a:t>
             </a:r>
             <a:r>
               <a:rPr lang="en-US" sz="950" dirty="0">

</xml_diff>